<commit_message>
docs+feat: add PPTX->PDF conversion, README, and currency formatting fix
Deck now auto-converts to PDF via LibreOffice headless mode after
generation (falls back to a note if soffice isn't installed). Fixed
negative dollar amounts rendering as "\$-695,888" instead of
"-\$695,888" in both the deck and memo. Added a full portfolio README
covering the engagement, framework, findings, deliverables, data
sources, local setup, and interview talking points.

Verified: no hardcoded absolute paths in analysis/api/data_collection,
frontend production build passes.

Co-Authored-By: Claude Sonnet 5 <noreply@anthropic.com>
</commit_message>
<xml_diff>
--- a/outputs/meridian_home_deck.pptx
+++ b/outputs/meridian_home_deck.pptx
@@ -4150,7 +4150,7 @@
               </a:defRPr>
             </a:pPr>
             <a:r>
-              <a:t>•  Combined risk-adjusted 3-year NPV is currently negative ($-695,888) at the standard 4,500 sqft / 10-FTE format — this is a real constraint, not a rounding error, and the phased approach below is how we manage that risk</a:t>
+              <a:t>•  Combined risk-adjusted 3-year NPV is currently negative (-$695,888) at the standard 4,500 sqft / 10-FTE format — this is a real constraint, not a rounding error, and the phased approach below is how we manage that risk</a:t>
             </a:r>
           </a:p>
           <a:p>
@@ -5565,7 +5565,7 @@
                 </a:solidFill>
                 <a:latin typeface="Calibri"/>
               </a:rPr>
-              <a:t>$-695,888</a:t>
+              <a:t>-$695,888</a:t>
             </a:r>
           </a:p>
         </p:txBody>

</xml_diff>